<commit_message>
slides: reflect resolved supervision (user-systemd) and TLS deploy-hook fix in Live-Server + Server-Access decks
</commit_message>
<xml_diff>
--- a/presentation/UNanofabTools/liveserver/slides/Live-Server.pptx
+++ b/presentation/UNanofabTools/liveserver/slides/Live-Server.pptx
@@ -602,7 +602,7 @@
           <a:p>
             <a:r>
               <a:rPr lang="en-US" dirty="0"/>
-              <a:t>Don't let the long weirdness list make this look worse than it is. The boring infrastructure is in good shape. OS is current. Firewall is conservative and configured correctly. TLS renewal is automatic and the timer is firing as expected. Web server and database have clean recent logs. SSH is key-only — no password brute force possible. Disk and memory have plenty of headroom. The gaps are operational — backups, supervision, alerting — not 'the server is on fire'.</a:t>
+              <a:t>Don't let the long weirdness list make this look worse than it is. The boring infrastructure is in good shape. OS is current. Firewall is conservative and configured correctly. TLS renewal is automatic and the timer is firing as expected. Web server and database have clean recent logs. SSH is key-only — no password brute force possible. Disk and memory have plenty of headroom. The gaps are operational — mainly alerting and a few cleanups (supervision and backups are now handled) — not 'the server is on fire'.</a:t>
             </a:r>
             <a:endParaRPr lang="en-US" dirty="0"/>
           </a:p>
@@ -778,7 +778,7 @@
           <a:p>
             <a:r>
               <a:rPr lang="en-US" dirty="0"/>
-              <a:t>Final recommendation list, split by who can do what. The Nanofab team has sudo as phelan but not root, and can't create UNIX accounts. So the left column is the Nanofab punch list: systemd supervision is the biggest reliability win, then the HTTP redirect, notifications, one patched phelan-side survey refresh, and a small cleanup pass. The right column is what needs IT — tightening the root key file mode, confirming the backup scope, and the two optional asks for per-person accounts or a DNS name. If you can only do one thing from the left column, do systemd; it eliminates the silent-failure mode for the website in one move.</a:t>
+              <a:t>Final recommendation list, split by who can do what. The Nanofab team has sudo as phelan but not root, and can't create UNIX accounts. So the left column is the Nanofab punch list: systemd supervision is the biggest reliability win, then the docs fix for the HTTP redirect, notifications, one patched phelan-side survey refresh, and a small cleanup pass. The right column is what needs IT — tightening the root key file mode, confirming the backup scope, and the two optional asks for per-person accounts or a DNS name. If you can only do one thing from the left column, do systemd; it eliminates the silent-failure mode for the website in one move.</a:t>
             </a:r>
             <a:endParaRPr lang="en-US" dirty="0"/>
           </a:p>
@@ -1218,7 +1218,7 @@
           <a:p>
             <a:r>
               <a:rPr lang="en-US" dirty="0"/>
-              <a:t>TLS health. The current certificate is well within its 90-day window, with 24 days remaining at the time of capture. The certbot systemd timer is firing twice a day exactly as it should and ran successfully about an hour before our snapshot. So this part of the system is auto-healing. The thing to watch for is if certbot.timer ever becomes inactive — then renewals stop and 30 days later the website starts throwing browser warnings.</a:t>
+              <a:t>TLS reality check. The certificate captured in the snapshot expired on Jun 23, 2026 and the site briefly showed a browser warning. The subtle part: certbot HAD auto-renewed on schedule (the new cert was valid to Aug 22), but nothing reloaded nginx, so nginx kept serving the old in-memory cert until it expired. The fix was to reload nginx and add a certbot deploy hook (/etc/letsencrypt/renewal-hooks/deploy/reload-nginx.sh) so every future renewal reloads nginx automatically. Now both halves are automatic; the thing to watch is that certbot.timer stays active.</a:t>
             </a:r>
             <a:endParaRPr lang="en-US" dirty="0"/>
           </a:p>
@@ -1306,7 +1306,7 @@
           <a:p>
             <a:r>
               <a:rPr lang="en-US" dirty="0"/>
-              <a:t>Quick health table. Left side: things that just work — including the VM-level backup, which runs off the box and is operated by University IT, not the Nanofab team. Cert renewal, log rotation, apt's daily update check, filesystem maintenance, NTP. All quiet, all on schedule. Right side: the gaps the Nanofab team can actually close on its own. The Flask app and the downloader have no supervisor. There's no path for the box to alert anyone when something fails. Bare HTTP doesn't redirect to HTTPS. And there are small cleanups. Each is fixable with sudo from the Nanofab side; together they're most of the operational risk on this box.</a:t>
+              <a:t>Quick health table. Left side: things that just work — including the VM-level backup, which runs off the box and is operated by University IT, not the Nanofab team. Cert renewal, log rotation, apt's daily update check, filesystem maintenance, NTP. All quiet, all on schedule — and, as of 2026-06-18, service supervision: the Flask app and downloader now run under user-level systemd, so that gap is closed. Right side: the gaps the Nanofab team can still close on its own. There's no path for the box to alert anyone when something fails. Bare HTTP doesn't redirect to HTTPS. And there are small cleanups. Each is fixable with sudo from the Nanofab side; together they're most of the operational risk on this box.</a:t>
             </a:r>
             <a:endParaRPr lang="en-US" dirty="0"/>
           </a:p>
@@ -6426,7 +6426,7 @@
                 <a:ea typeface="Calibri" pitchFamily="34" charset="-122"/>
                 <a:cs typeface="Calibri" pitchFamily="34" charset="-120"/>
               </a:rPr>
-              <a:t>Current cert  </a:t>
+              <a:t>What happened  </a:t>
             </a:r>
             <a:pPr indent="0" marL="0">
               <a:buNone/>
@@ -6440,7 +6440,7 @@
                 <a:ea typeface="Calibri" pitchFamily="34" charset="-122"/>
                 <a:cs typeface="Calibri" pitchFamily="34" charset="-120"/>
               </a:rPr>
-              <a:t>expires Jun 23, 2026 — about 24 days from the snapshot.</a:t>
+              <a:t>the snapshot cert (exp Jun 23, 2026) DID expire — site showed 'not private' that day.</a:t>
             </a:r>
             <a:endParaRPr lang="en-US" sz="1400" dirty="0"/>
           </a:p>
@@ -6538,7 +6538,7 @@
                 <a:ea typeface="Calibri" pitchFamily="34" charset="-122"/>
                 <a:cs typeface="Calibri" pitchFamily="34" charset="-120"/>
               </a:rPr>
-              <a:t>Auto-renewal  </a:t>
+              <a:t>Root cause  </a:t>
             </a:r>
             <a:pPr indent="0" marL="0">
               <a:buNone/>
@@ -6552,7 +6552,7 @@
                 <a:ea typeface="Calibri" pitchFamily="34" charset="-122"/>
                 <a:cs typeface="Calibri" pitchFamily="34" charset="-120"/>
               </a:rPr>
-              <a:t>certbot.timer runs twice daily; last ran 1h 13m before snapshot.</a:t>
+              <a:t>certbot auto-renewed (new cert valid to Aug 22), but nginx was never reloaded, so it served the old cert from memory.</a:t>
             </a:r>
             <a:endParaRPr lang="en-US" sz="1400" dirty="0"/>
           </a:p>
@@ -6650,7 +6650,7 @@
                 <a:ea typeface="Calibri" pitchFamily="34" charset="-122"/>
                 <a:cs typeface="Calibri" pitchFamily="34" charset="-120"/>
               </a:rPr>
-              <a:t>Issuer  </a:t>
+              <a:t>Fix (2026-06-23)  </a:t>
             </a:r>
             <a:pPr indent="0" marL="0">
               <a:buNone/>
@@ -6664,7 +6664,7 @@
                 <a:ea typeface="Calibri" pitchFamily="34" charset="-122"/>
                 <a:cs typeface="Calibri" pitchFamily="34" charset="-120"/>
               </a:rPr>
-              <a:t>Let's Encrypt CN=E7. Standard 90-day cert.</a:t>
+              <a:t>reload nginx + a certbot deploy hook (reload-nginx.sh) so every future renewal reloads nginx.</a:t>
             </a:r>
             <a:endParaRPr lang="en-US" sz="1400" dirty="0"/>
           </a:p>
@@ -6776,7 +6776,7 @@
                 <a:ea typeface="Calibri" pitchFamily="34" charset="-122"/>
                 <a:cs typeface="Calibri" pitchFamily="34" charset="-120"/>
               </a:rPr>
-              <a:t>Healthy. No human action needed unless certbot.timer ever stops.</a:t>
+              <a:t>Renewal is automatic AND nginx now reloads on renewal. Watch that certbot.timer stays active.</a:t>
             </a:r>
             <a:endParaRPr lang="en-US" sz="1400" dirty="0"/>
           </a:p>
@@ -7156,67 +7156,6 @@
             </a:r>
             <a:endParaRPr lang="en-US" sz="1350" dirty="0"/>
           </a:p>
-        </p:txBody>
-      </p:sp>
-      <p:sp>
-        <p:nvSpPr>
-          <p:cNvPr id="9" name="Text 7"/>
-          <p:cNvSpPr/>
-          <p:nvPr/>
-        </p:nvSpPr>
-        <p:spPr>
-          <a:xfrm>
-            <a:off x="6323076" y="1325880"/>
-            <a:ext cx="5225796" cy="411480"/>
-          </a:xfrm>
-          <a:prstGeom prst="rect">
-            <a:avLst/>
-          </a:prstGeom>
-          <a:noFill/>
-          <a:ln/>
-        </p:spPr>
-        <p:txBody>
-          <a:bodyPr wrap="square" lIns="0" tIns="0" rIns="0" bIns="0" rtlCol="0" anchor="ctr"/>
-          <a:lstStyle/>
-          <a:p>
-            <a:pPr indent="0" marL="0">
-              <a:buNone/>
-            </a:pPr>
-            <a:r>
-              <a:rPr lang="en-US" sz="1600" b="1" dirty="0">
-                <a:solidFill>
-                  <a:srgbClr val="CC0000"/>
-                </a:solidFill>
-                <a:latin typeface="Georgia" pitchFamily="34" charset="0"/>
-                <a:ea typeface="Georgia" pitchFamily="34" charset="-122"/>
-                <a:cs typeface="Georgia" pitchFamily="34" charset="-120"/>
-              </a:rPr>
-              <a:t>Gaps the Nanofab team can close</a:t>
-            </a:r>
-            <a:endParaRPr lang="en-US" sz="1600" dirty="0"/>
-          </a:p>
-        </p:txBody>
-      </p:sp>
-      <p:sp>
-        <p:nvSpPr>
-          <p:cNvPr id="10" name="Text 8"/>
-          <p:cNvSpPr/>
-          <p:nvPr/>
-        </p:nvSpPr>
-        <p:spPr>
-          <a:xfrm>
-            <a:off x="6323076" y="1783080"/>
-            <a:ext cx="5225796" cy="4526280"/>
-          </a:xfrm>
-          <a:prstGeom prst="rect">
-            <a:avLst/>
-          </a:prstGeom>
-          <a:noFill/>
-          <a:ln/>
-        </p:spPr>
-        <p:txBody>
-          <a:bodyPr wrap="square" lIns="0" tIns="0" rIns="0" bIns="0" rtlCol="0" anchor="t"/>
-          <a:lstStyle/>
           <a:p>
             <a:pPr marL="203200" indent="-203200">
               <a:spcAft>
@@ -7234,10 +7173,71 @@
                 <a:ea typeface="Calibri" pitchFamily="34" charset="-122"/>
                 <a:cs typeface="Calibri" pitchFamily="34" charset="-120"/>
               </a:rPr>
-              <a:t>Service supervision for Flask / downloader</a:t>
+              <a:t>Service supervision — Flask + downloader (user-systemd, 2026-06-18)</a:t>
             </a:r>
             <a:endParaRPr lang="en-US" sz="1350" dirty="0"/>
           </a:p>
+        </p:txBody>
+      </p:sp>
+      <p:sp>
+        <p:nvSpPr>
+          <p:cNvPr id="9" name="Text 7"/>
+          <p:cNvSpPr/>
+          <p:nvPr/>
+        </p:nvSpPr>
+        <p:spPr>
+          <a:xfrm>
+            <a:off x="6323076" y="1325880"/>
+            <a:ext cx="5225796" cy="411480"/>
+          </a:xfrm>
+          <a:prstGeom prst="rect">
+            <a:avLst/>
+          </a:prstGeom>
+          <a:noFill/>
+          <a:ln/>
+        </p:spPr>
+        <p:txBody>
+          <a:bodyPr wrap="square" lIns="0" tIns="0" rIns="0" bIns="0" rtlCol="0" anchor="ctr"/>
+          <a:lstStyle/>
+          <a:p>
+            <a:pPr indent="0" marL="0">
+              <a:buNone/>
+            </a:pPr>
+            <a:r>
+              <a:rPr lang="en-US" sz="1600" b="1" dirty="0">
+                <a:solidFill>
+                  <a:srgbClr val="CC0000"/>
+                </a:solidFill>
+                <a:latin typeface="Georgia" pitchFamily="34" charset="0"/>
+                <a:ea typeface="Georgia" pitchFamily="34" charset="-122"/>
+                <a:cs typeface="Georgia" pitchFamily="34" charset="-120"/>
+              </a:rPr>
+              <a:t>Gaps the Nanofab team can close</a:t>
+            </a:r>
+            <a:endParaRPr lang="en-US" sz="1600" dirty="0"/>
+          </a:p>
+        </p:txBody>
+      </p:sp>
+      <p:sp>
+        <p:nvSpPr>
+          <p:cNvPr id="10" name="Text 8"/>
+          <p:cNvSpPr/>
+          <p:nvPr/>
+        </p:nvSpPr>
+        <p:spPr>
+          <a:xfrm>
+            <a:off x="6323076" y="1783080"/>
+            <a:ext cx="5225796" cy="4526280"/>
+          </a:xfrm>
+          <a:prstGeom prst="rect">
+            <a:avLst/>
+          </a:prstGeom>
+          <a:noFill/>
+          <a:ln/>
+        </p:spPr>
+        <p:txBody>
+          <a:bodyPr wrap="square" lIns="0" tIns="0" rIns="0" bIns="0" rtlCol="0" anchor="t"/>
+          <a:lstStyle/>
           <a:p>
             <a:pPr marL="203200" indent="-203200">
               <a:spcAft>

</xml_diff>